<commit_message>
Minor changes to PDP and CVP lectures.
</commit_message>
<xml_diff>
--- a/Day 2 Part 2/D2P2.pptx
+++ b/Day 2 Part 2/D2P2.pptx
@@ -296,23 +296,30 @@
 </p:presentation>
 </file>
 
-<file path=ppt/revisionInfo.xml><?xml version="1.0" encoding="utf-8"?>
-<p1510:revInfo xmlns:a="http://schemas.openxmlformats.org/drawingml/2006/main" xmlns:r="http://schemas.openxmlformats.org/officeDocument/2006/relationships" xmlns:p1510="http://schemas.microsoft.com/office/powerpoint/2015/10/main">
-  <p1510:revLst>
-    <p1510:client id="{ADB41970-3D76-44B5-A3FE-07274F98D8DC}" v="1" dt="2026-03-15T14:25:37.795"/>
-  </p1510:revLst>
-</p1510:revInfo>
-</file>
-
 <file path=ppt/changesInfos/changesInfo1.xml><?xml version="1.0" encoding="utf-8"?>
 <pc:chgInfo xmlns:a="http://schemas.openxmlformats.org/drawingml/2006/main" xmlns:r="http://schemas.openxmlformats.org/officeDocument/2006/relationships" xmlns:ac="http://schemas.microsoft.com/office/drawing/2013/main/command" xmlns:pc="http://schemas.microsoft.com/office/powerpoint/2013/main/command">
   <pc:docChgLst>
     <pc:chgData name="Matthieu De Mari" userId="dfb708c9-d8dc-439f-9a3b-c772bf4a311c" providerId="ADAL" clId="{81E9B007-0C2C-493E-9B93-55A62C9C1F12}"/>
     <pc:docChg chg="undo custSel addSld delSld modSld delSection modSection">
-      <pc:chgData name="Matthieu De Mari" userId="dfb708c9-d8dc-439f-9a3b-c772bf4a311c" providerId="ADAL" clId="{81E9B007-0C2C-493E-9B93-55A62C9C1F12}" dt="2026-03-15T14:26:11.675" v="545" actId="20577"/>
+      <pc:chgData name="Matthieu De Mari" userId="dfb708c9-d8dc-439f-9a3b-c772bf4a311c" providerId="ADAL" clId="{81E9B007-0C2C-493E-9B93-55A62C9C1F12}" dt="2026-03-27T08:33:51.283" v="603" actId="20577"/>
       <pc:docMkLst>
         <pc:docMk/>
       </pc:docMkLst>
+      <pc:sldChg chg="modSp mod">
+        <pc:chgData name="Matthieu De Mari" userId="dfb708c9-d8dc-439f-9a3b-c772bf4a311c" providerId="ADAL" clId="{81E9B007-0C2C-493E-9B93-55A62C9C1F12}" dt="2026-03-27T03:23:52.839" v="602" actId="20577"/>
+        <pc:sldMkLst>
+          <pc:docMk/>
+          <pc:sldMk cId="1921397945" sldId="383"/>
+        </pc:sldMkLst>
+        <pc:spChg chg="mod">
+          <ac:chgData name="Matthieu De Mari" userId="dfb708c9-d8dc-439f-9a3b-c772bf4a311c" providerId="ADAL" clId="{81E9B007-0C2C-493E-9B93-55A62C9C1F12}" dt="2026-03-27T03:23:52.839" v="602" actId="20577"/>
+          <ac:spMkLst>
+            <pc:docMk/>
+            <pc:sldMk cId="1921397945" sldId="383"/>
+            <ac:spMk id="3" creationId="{4E3EB5A2-1EBE-6555-85E5-4CA6DEF3845D}"/>
+          </ac:spMkLst>
+        </pc:spChg>
+      </pc:sldChg>
       <pc:sldChg chg="modSp mod">
         <pc:chgData name="Matthieu De Mari" userId="dfb708c9-d8dc-439f-9a3b-c772bf4a311c" providerId="ADAL" clId="{81E9B007-0C2C-493E-9B93-55A62C9C1F12}" dt="2026-03-15T14:25:49.806" v="511" actId="1076"/>
         <pc:sldMkLst>
@@ -359,6 +366,21 @@
           </ac:spMkLst>
         </pc:spChg>
       </pc:sldChg>
+      <pc:sldChg chg="modSp mod">
+        <pc:chgData name="Matthieu De Mari" userId="dfb708c9-d8dc-439f-9a3b-c772bf4a311c" providerId="ADAL" clId="{81E9B007-0C2C-493E-9B93-55A62C9C1F12}" dt="2026-03-27T08:33:51.283" v="603" actId="20577"/>
+        <pc:sldMkLst>
+          <pc:docMk/>
+          <pc:sldMk cId="557429466" sldId="785"/>
+        </pc:sldMkLst>
+        <pc:spChg chg="mod">
+          <ac:chgData name="Matthieu De Mari" userId="dfb708c9-d8dc-439f-9a3b-c772bf4a311c" providerId="ADAL" clId="{81E9B007-0C2C-493E-9B93-55A62C9C1F12}" dt="2026-03-27T08:33:51.283" v="603" actId="20577"/>
+          <ac:spMkLst>
+            <pc:docMk/>
+            <pc:sldMk cId="557429466" sldId="785"/>
+            <ac:spMk id="3" creationId="{65399E50-9E84-8D67-B55F-073C06C3D10E}"/>
+          </ac:spMkLst>
+        </pc:spChg>
+      </pc:sldChg>
     </pc:docChg>
   </pc:docChgLst>
 </pc:chgInfo>
@@ -446,7 +468,7 @@
           <a:p>
             <a:fld id="{61478373-EB31-4867-8CF0-FA31364748A5}" type="datetimeFigureOut">
               <a:rPr lang="en-GB" smtClean="0"/>
-              <a:t>15/03/2026</a:t>
+              <a:t>27/03/2026</a:t>
             </a:fld>
             <a:endParaRPr lang="en-GB"/>
           </a:p>
@@ -863,7 +885,7 @@
           <a:p>
             <a:fld id="{E85DF616-B21E-4EF6-A6A5-95E2FB3EB1A1}" type="datetimeFigureOut">
               <a:rPr lang="en-GB" smtClean="0"/>
-              <a:t>15/03/2026</a:t>
+              <a:t>27/03/2026</a:t>
             </a:fld>
             <a:endParaRPr lang="en-GB"/>
           </a:p>
@@ -1063,7 +1085,7 @@
           <a:p>
             <a:fld id="{E85DF616-B21E-4EF6-A6A5-95E2FB3EB1A1}" type="datetimeFigureOut">
               <a:rPr lang="en-GB" smtClean="0"/>
-              <a:t>15/03/2026</a:t>
+              <a:t>27/03/2026</a:t>
             </a:fld>
             <a:endParaRPr lang="en-GB"/>
           </a:p>
@@ -1273,7 +1295,7 @@
           <a:p>
             <a:fld id="{E85DF616-B21E-4EF6-A6A5-95E2FB3EB1A1}" type="datetimeFigureOut">
               <a:rPr lang="en-GB" smtClean="0"/>
-              <a:t>15/03/2026</a:t>
+              <a:t>27/03/2026</a:t>
             </a:fld>
             <a:endParaRPr lang="en-GB"/>
           </a:p>
@@ -1473,7 +1495,7 @@
           <a:p>
             <a:fld id="{E85DF616-B21E-4EF6-A6A5-95E2FB3EB1A1}" type="datetimeFigureOut">
               <a:rPr lang="en-GB" smtClean="0"/>
-              <a:t>15/03/2026</a:t>
+              <a:t>27/03/2026</a:t>
             </a:fld>
             <a:endParaRPr lang="en-GB"/>
           </a:p>
@@ -1749,7 +1771,7 @@
           <a:p>
             <a:fld id="{E85DF616-B21E-4EF6-A6A5-95E2FB3EB1A1}" type="datetimeFigureOut">
               <a:rPr lang="en-GB" smtClean="0"/>
-              <a:t>15/03/2026</a:t>
+              <a:t>27/03/2026</a:t>
             </a:fld>
             <a:endParaRPr lang="en-GB"/>
           </a:p>
@@ -2017,7 +2039,7 @@
           <a:p>
             <a:fld id="{E85DF616-B21E-4EF6-A6A5-95E2FB3EB1A1}" type="datetimeFigureOut">
               <a:rPr lang="en-GB" smtClean="0"/>
-              <a:t>15/03/2026</a:t>
+              <a:t>27/03/2026</a:t>
             </a:fld>
             <a:endParaRPr lang="en-GB"/>
           </a:p>
@@ -2432,7 +2454,7 @@
           <a:p>
             <a:fld id="{E85DF616-B21E-4EF6-A6A5-95E2FB3EB1A1}" type="datetimeFigureOut">
               <a:rPr lang="en-GB" smtClean="0"/>
-              <a:t>15/03/2026</a:t>
+              <a:t>27/03/2026</a:t>
             </a:fld>
             <a:endParaRPr lang="en-GB"/>
           </a:p>
@@ -2574,7 +2596,7 @@
           <a:p>
             <a:fld id="{E85DF616-B21E-4EF6-A6A5-95E2FB3EB1A1}" type="datetimeFigureOut">
               <a:rPr lang="en-GB" smtClean="0"/>
-              <a:t>15/03/2026</a:t>
+              <a:t>27/03/2026</a:t>
             </a:fld>
             <a:endParaRPr lang="en-GB"/>
           </a:p>
@@ -2687,7 +2709,7 @@
           <a:p>
             <a:fld id="{E85DF616-B21E-4EF6-A6A5-95E2FB3EB1A1}" type="datetimeFigureOut">
               <a:rPr lang="en-GB" smtClean="0"/>
-              <a:t>15/03/2026</a:t>
+              <a:t>27/03/2026</a:t>
             </a:fld>
             <a:endParaRPr lang="en-GB"/>
           </a:p>
@@ -3000,7 +3022,7 @@
           <a:p>
             <a:fld id="{E85DF616-B21E-4EF6-A6A5-95E2FB3EB1A1}" type="datetimeFigureOut">
               <a:rPr lang="en-GB" smtClean="0"/>
-              <a:t>15/03/2026</a:t>
+              <a:t>27/03/2026</a:t>
             </a:fld>
             <a:endParaRPr lang="en-GB"/>
           </a:p>
@@ -3289,7 +3311,7 @@
           <a:p>
             <a:fld id="{E85DF616-B21E-4EF6-A6A5-95E2FB3EB1A1}" type="datetimeFigureOut">
               <a:rPr lang="en-GB" smtClean="0"/>
-              <a:t>15/03/2026</a:t>
+              <a:t>27/03/2026</a:t>
             </a:fld>
             <a:endParaRPr lang="en-GB"/>
           </a:p>
@@ -3532,7 +3554,7 @@
           <a:p>
             <a:fld id="{E85DF616-B21E-4EF6-A6A5-95E2FB3EB1A1}" type="datetimeFigureOut">
               <a:rPr lang="en-GB" smtClean="0"/>
-              <a:t>15/03/2026</a:t>
+              <a:t>27/03/2026</a:t>
             </a:fld>
             <a:endParaRPr lang="en-GB"/>
           </a:p>
@@ -9081,20 +9103,17 @@
             </a:r>
             <a:r>
               <a:rPr lang="en-GB" b="1" dirty="0"/>
-              <a:t>Stochastic Mini-Batch gradient descent</a:t>
-            </a:r>
-            <a:r>
-              <a:rPr lang="en-GB" dirty="0"/>
-              <a:t>, with </a:t>
-            </a:r>
-            <a:r>
-              <a:rPr lang="en-GB" b="1" dirty="0"/>
-              <a:t>Adam</a:t>
-            </a:r>
-            <a:r>
-              <a:rPr lang="en-GB" dirty="0"/>
-              <a:t> as its optimizer,</a:t>
-            </a:r>
+              <a:t>simple gradient descent algorithm </a:t>
+            </a:r>
+            <a:r>
+              <a:rPr lang="en-GB" b="1"/>
+              <a:t>for updates</a:t>
+            </a:r>
+            <a:r>
+              <a:rPr lang="en-GB"/>
+              <a:t>,</a:t>
+            </a:r>
+            <a:endParaRPr lang="en-GB" dirty="0"/>
           </a:p>
           <a:p>
             <a:r>
@@ -16572,13 +16591,6 @@
             <a:r>
               <a:rPr lang="en-GB" dirty="0"/>
               <a:t>.</a:t>
-            </a:r>
-          </a:p>
-          <a:p>
-            <a:pPr lvl="1"/>
-            <a:r>
-              <a:rPr lang="en-GB" dirty="0"/>
-              <a:t>(More on this on Week 13!)</a:t>
             </a:r>
           </a:p>
           <a:p>

</xml_diff>